<commit_message>
Add Data Quality Assessment notebook, renumber pipeline (01-08)
</commit_message>
<xml_diff>
--- a/Präsentation/Presentation1.pptx
+++ b/Präsentation/Presentation1.pptx
@@ -282,7 +282,7 @@
           <a:p>
             <a:fld id="{652642F8-4030-468B-846F-DE3B6AB6CE0D}" type="datetimeFigureOut">
               <a:rPr lang="de-DE" smtClean="0"/>
-              <a:t>05.04.26</a:t>
+              <a:t>06.04.26</a:t>
             </a:fld>
             <a:endParaRPr lang="de-DE"/>
           </a:p>
@@ -447,7 +447,7 @@
           <a:p>
             <a:fld id="{E1AB2040-EA4D-4002-BC41-13AC0377AF84}" type="datetimeFigureOut">
               <a:rPr lang="de-DE" smtClean="0"/>
-              <a:t>05.04.26</a:t>
+              <a:t>06.04.26</a:t>
             </a:fld>
             <a:endParaRPr lang="de-DE"/>
           </a:p>
@@ -6736,7 +6736,7 @@
             </a:r>
             <a:r>
               <a:rPr lang="de-DE" sz="1800" dirty="0"/>
-              <a:t>Semantische Lücke zwischen 496 spezifischen Polizei-Delikten und 26 abstrakten Justiz-Kategorien.</a:t>
+              <a:t>Semantische Lücke zwischen 905 spezifischen Polizei-Delikten und 21 abstrakten Justiz-Kategorien.</a:t>
             </a:r>
           </a:p>
           <a:p>
@@ -7309,7 +7309,7 @@
             </a:r>
             <a:r>
               <a:rPr lang="de-DE" sz="1600" dirty="0"/>
-              <a:t> Sichtbare Nullwerte in den polizeilichen Zeitreihen (z. B. 1984–1986, 2020) durch Platzhalter im Ursprungsformat.</a:t>
+              <a:t> Sichtbare Nullwerte in den polizeilichen Zeitreihen (z. B. 1984–1986) durch Platzhalter im Ursprungsformat.</a:t>
             </a:r>
           </a:p>
           <a:p>

</xml_diff>